<commit_message>
Updated the power point slide
</commit_message>
<xml_diff>
--- a/GROUP4_PROJECT.pptx
+++ b/GROUP4_PROJECT.pptx
@@ -81,7 +81,7 @@
         <p:txBody>
           <a:bodyPr/>
           <a:p>
-            <a:fld id="{3F8C3F0A-D28B-45DB-8E44-15FA6457ED2A}" type="slidenum">
+            <a:fld id="{9B785483-3CA4-4744-956C-6623682900F5}" type="slidenum">
               <a:t>&lt;#&gt;</a:t>
             </a:fld>
           </a:p>
@@ -376,7 +376,7 @@
         <p:txBody>
           <a:bodyPr/>
           <a:p>
-            <a:fld id="{CBFDC9BA-63ED-4922-91F1-5C08A0B8E6B8}" type="slidenum">
+            <a:fld id="{A6CCA67A-A5CE-498D-852D-89092A92EF80}" type="slidenum">
               <a:t>&lt;#&gt;</a:t>
             </a:fld>
           </a:p>
@@ -628,7 +628,7 @@
         <p:txBody>
           <a:bodyPr/>
           <a:p>
-            <a:fld id="{001396B9-F52A-4663-BD09-5D78250B3B6F}" type="slidenum">
+            <a:fld id="{7685F535-7F66-4020-AA10-0CEBBF440F9E}" type="slidenum">
               <a:t>&lt;#&gt;</a:t>
             </a:fld>
           </a:p>
@@ -794,7 +794,7 @@
         <p:txBody>
           <a:bodyPr/>
           <a:p>
-            <a:fld id="{75B69856-B4BE-400F-BF47-6F14E1816C7D}" type="slidenum">
+            <a:fld id="{9C0EA193-8181-4793-9BA2-5104BCEE0C1D}" type="slidenum">
               <a:t>&lt;#&gt;</a:t>
             </a:fld>
           </a:p>
@@ -957,7 +957,7 @@
         <p:txBody>
           <a:bodyPr/>
           <a:p>
-            <a:fld id="{4A53AD7A-FC89-4998-BE81-7B5B532D0EDE}" type="slidenum">
+            <a:fld id="{3101F0F4-CB56-45F6-AED0-204D2E63095B}" type="slidenum">
               <a:t>&lt;#&gt;</a:t>
             </a:fld>
           </a:p>
@@ -1471,7 +1471,7 @@
             <a:pPr indent="0" algn="r">
               <a:buNone/>
             </a:pPr>
-            <a:fld id="{99D44E08-F854-4DFC-BA1C-C5C18263B917}" type="slidenum">
+            <a:fld id="{368D1E63-B3C1-43B8-BFB6-FCD7E3B2E4B8}" type="slidenum">
               <a:rPr b="0" lang="en-NG" sz="1400" spc="-1" strike="noStrike">
                 <a:solidFill>
                   <a:srgbClr val="ffffff"/>
@@ -2054,25 +2054,7 @@
                 </a:solidFill>
                 <a:latin typeface="Arial"/>
               </a:rPr>
-              <a:t> – </a:t>
-            </a:r>
-            <a:r>
-              <a:rPr b="0" lang="en-NG" sz="2400" spc="-1" strike="noStrike">
-                <a:solidFill>
-                  <a:srgbClr val="ffffff"/>
-                </a:solidFill>
-                <a:latin typeface="Arial"/>
-              </a:rPr>
-              <a:t>Wrote tests covering the GET </a:t>
-            </a:r>
-            <a:r>
-              <a:rPr b="0" lang="en-NG" sz="2400" spc="-1" strike="noStrike">
-                <a:solidFill>
-                  <a:srgbClr val="ffffff"/>
-                </a:solidFill>
-                <a:latin typeface="Arial"/>
-              </a:rPr>
-              <a:t>and DELETE routes.</a:t>
+              <a:t> – Wrote tests covering the GET and DELETE routes.</a:t>
             </a:r>
             <a:endParaRPr b="0" lang="en-NG" sz="2400" spc="-1" strike="noStrike">
               <a:solidFill>
@@ -2114,25 +2096,7 @@
                 </a:solidFill>
                 <a:latin typeface="Arial"/>
               </a:rPr>
-              <a:t> – </a:t>
-            </a:r>
-            <a:r>
-              <a:rPr b="0" lang="en-NG" sz="2400" spc="-1" strike="noStrike">
-                <a:solidFill>
-                  <a:srgbClr val="ffffff"/>
-                </a:solidFill>
-                <a:latin typeface="Arial"/>
-              </a:rPr>
-              <a:t>implemented the routes for </a:t>
-            </a:r>
-            <a:r>
-              <a:rPr b="0" lang="en-NG" sz="2400" spc="-1" strike="noStrike">
-                <a:solidFill>
-                  <a:srgbClr val="ffffff"/>
-                </a:solidFill>
-                <a:latin typeface="Arial"/>
-              </a:rPr>
-              <a:t>creating and updating notes.</a:t>
+              <a:t> – implemented the routes for creating and updating notes.</a:t>
             </a:r>
             <a:endParaRPr b="0" lang="en-NG" sz="2400" spc="-1" strike="noStrike">
               <a:solidFill>
@@ -2174,25 +2138,7 @@
                 </a:solidFill>
                 <a:latin typeface="Arial"/>
               </a:rPr>
-              <a:t> – </a:t>
-            </a:r>
-            <a:r>
-              <a:rPr b="0" lang="en-NG" sz="2400" spc="-1" strike="noStrike">
-                <a:solidFill>
-                  <a:srgbClr val="ffffff"/>
-                </a:solidFill>
-                <a:latin typeface="Arial"/>
-              </a:rPr>
-              <a:t>Wrote tests covering all </a:t>
-            </a:r>
-            <a:r>
-              <a:rPr b="0" lang="en-NG" sz="2400" spc="-1" strike="noStrike">
-                <a:solidFill>
-                  <a:srgbClr val="ffffff"/>
-                </a:solidFill>
-                <a:latin typeface="Arial"/>
-              </a:rPr>
-              <a:t>remaining routes.</a:t>
+              <a:t> – Wrote tests covering all remaining routes.</a:t>
             </a:r>
             <a:endParaRPr b="0" lang="en-NG" sz="2400" spc="-1" strike="noStrike">
               <a:solidFill>
@@ -2234,34 +2180,7 @@
                 </a:solidFill>
                 <a:latin typeface="Arial"/>
               </a:rPr>
-              <a:t> – </a:t>
-            </a:r>
-            <a:r>
-              <a:rPr b="0" lang="en-NG" sz="2400" spc="-1" strike="noStrike">
-                <a:solidFill>
-                  <a:srgbClr val="ffffff"/>
-                </a:solidFill>
-                <a:latin typeface="Arial"/>
-              </a:rPr>
-              <a:t>Implemented handling for </a:t>
-            </a:r>
-            <a:r>
-              <a:rPr b="0" lang="en-NG" sz="2400" spc="-1" strike="noStrike">
-                <a:solidFill>
-                  <a:srgbClr val="ffffff"/>
-                </a:solidFill>
-                <a:latin typeface="Arial"/>
-              </a:rPr>
-              <a:t>requests to routes that don’t </a:t>
-            </a:r>
-            <a:r>
-              <a:rPr b="0" lang="en-NG" sz="2400" spc="-1" strike="noStrike">
-                <a:solidFill>
-                  <a:srgbClr val="ffffff"/>
-                </a:solidFill>
-                <a:latin typeface="Arial"/>
-              </a:rPr>
-              <a:t>exist.</a:t>
+              <a:t> – Implemented handling for requests to routes that don’t exist.</a:t>
             </a:r>
             <a:endParaRPr b="0" lang="en-NG" sz="2400" spc="-1" strike="noStrike">
               <a:solidFill>
@@ -3079,7 +2998,25 @@
                 </a:solidFill>
                 <a:latin typeface="Arial"/>
               </a:rPr>
-              <a:t>Export Postman Collecton v2.1 into the postman/ repostory directory for team replication</a:t>
+              <a:t>Export Postman Collecton v2.1 </a:t>
+            </a:r>
+            <a:r>
+              <a:rPr b="0" lang="en-NG" sz="2200" spc="-1" strike="noStrike">
+                <a:solidFill>
+                  <a:srgbClr val="ffffff"/>
+                </a:solidFill>
+                <a:latin typeface="Arial"/>
+              </a:rPr>
+              <a:t>into the postman/ repostory </a:t>
+            </a:r>
+            <a:r>
+              <a:rPr b="0" lang="en-NG" sz="2200" spc="-1" strike="noStrike">
+                <a:solidFill>
+                  <a:srgbClr val="ffffff"/>
+                </a:solidFill>
+                <a:latin typeface="Arial"/>
+              </a:rPr>
+              <a:t>directory for team replication</a:t>
             </a:r>
             <a:endParaRPr b="1" i="1" lang="en-NG" sz="2200" spc="-1" strike="noStrike">
               <a:solidFill>
@@ -3159,7 +3096,25 @@
                 </a:solidFill>
                 <a:latin typeface="Arial"/>
               </a:rPr>
-              <a:t>Ensures invalid input payloada or missing resource Ids return predictable HTTP status codes.</a:t>
+              <a:t>Ensures invalid input payloada or </a:t>
+            </a:r>
+            <a:r>
+              <a:rPr b="0" lang="en-NG" sz="2000" spc="-1" strike="noStrike">
+                <a:solidFill>
+                  <a:srgbClr val="ffffff"/>
+                </a:solidFill>
+                <a:latin typeface="Arial"/>
+              </a:rPr>
+              <a:t>missing resource Ids return </a:t>
+            </a:r>
+            <a:r>
+              <a:rPr b="0" lang="en-NG" sz="2000" spc="-1" strike="noStrike">
+                <a:solidFill>
+                  <a:srgbClr val="ffffff"/>
+                </a:solidFill>
+                <a:latin typeface="Arial"/>
+              </a:rPr>
+              <a:t>predictable HTTP status codes.</a:t>
             </a:r>
             <a:endParaRPr b="1" i="1" lang="en-NG" sz="2000" spc="-1" strike="noStrike">
               <a:solidFill>
@@ -4632,7 +4587,16 @@
                 </a:solidFill>
                 <a:latin typeface="Arial"/>
               </a:rPr>
-              <a:t>1. Automated tests (vitest) – covering 4 layers of the application separately:</a:t>
+              <a:t>1. Automated tests (vitest) – covering 4 layers of the application </a:t>
+            </a:r>
+            <a:r>
+              <a:rPr b="0" lang="en-NG" sz="2400" spc="-1" strike="noStrike">
+                <a:solidFill>
+                  <a:srgbClr val="ffffff"/>
+                </a:solidFill>
+                <a:latin typeface="Arial"/>
+              </a:rPr>
+              <a:t>separately:</a:t>
             </a:r>
             <a:endParaRPr b="0" lang="en-NG" sz="2400" spc="-1" strike="noStrike">
               <a:solidFill>
@@ -4660,7 +4624,16 @@
                 </a:solidFill>
                 <a:latin typeface="Arial"/>
               </a:rPr>
-              <a:t>Repository layer( noteRepo.test.js) – verifies database operations woek correctly in isolation</a:t>
+              <a:t>Repository layer( noteRepo.test.js) – verifies database </a:t>
+            </a:r>
+            <a:r>
+              <a:rPr b="0" lang="en-NG" sz="2400" spc="-1" strike="noStrike">
+                <a:solidFill>
+                  <a:srgbClr val="ffffff"/>
+                </a:solidFill>
+                <a:latin typeface="Arial"/>
+              </a:rPr>
+              <a:t>operations woek correctly in isolation</a:t>
             </a:r>
             <a:endParaRPr b="0" lang="en-NG" sz="2400" spc="-1" strike="noStrike">
               <a:solidFill>
@@ -4688,7 +4661,16 @@
                 </a:solidFill>
                 <a:latin typeface="Arial"/>
               </a:rPr>
-              <a:t>Controller layer (noteController.test.js) – Verifies request-handling logic</a:t>
+              <a:t>Controller layer (noteController.test.js) – Verifies request-</a:t>
+            </a:r>
+            <a:r>
+              <a:rPr b="0" lang="en-NG" sz="2400" spc="-1" strike="noStrike">
+                <a:solidFill>
+                  <a:srgbClr val="ffffff"/>
+                </a:solidFill>
+                <a:latin typeface="Arial"/>
+              </a:rPr>
+              <a:t>handling logic</a:t>
             </a:r>
             <a:endParaRPr b="0" lang="en-NG" sz="2400" spc="-1" strike="noStrike">
               <a:solidFill>
@@ -4716,7 +4698,16 @@
                 </a:solidFill>
                 <a:latin typeface="Arial"/>
               </a:rPr>
-              <a:t>Route layer(noteRoute.test.js) – Verifies the full behaviour end – to – end.</a:t>
+              <a:t>Route layer(noteRoute.test.js) – Verifies the full behaviour end – </a:t>
+            </a:r>
+            <a:r>
+              <a:rPr b="0" lang="en-NG" sz="2400" spc="-1" strike="noStrike">
+                <a:solidFill>
+                  <a:srgbClr val="ffffff"/>
+                </a:solidFill>
+                <a:latin typeface="Arial"/>
+              </a:rPr>
+              <a:t>to – end.</a:t>
             </a:r>
             <a:endParaRPr b="0" lang="en-NG" sz="2400" spc="-1" strike="noStrike">
               <a:solidFill>
@@ -4744,7 +4735,16 @@
                 </a:solidFill>
                 <a:latin typeface="Arial"/>
               </a:rPr>
-              <a:t>Validation middleware (validation.middleware.test.js) – verifies bad/missing data is correctly rejected.</a:t>
+              <a:t>Validation middleware (validation.middleware.test.js) – verifies </a:t>
+            </a:r>
+            <a:r>
+              <a:rPr b="0" lang="en-NG" sz="2400" spc="-1" strike="noStrike">
+                <a:solidFill>
+                  <a:srgbClr val="ffffff"/>
+                </a:solidFill>
+                <a:latin typeface="Arial"/>
+              </a:rPr>
+              <a:t>bad/missing data is correctly rejected.</a:t>
             </a:r>
             <a:endParaRPr b="0" lang="en-NG" sz="2400" spc="-1" strike="noStrike">
               <a:solidFill>
@@ -5356,8 +5356,8 @@
         </p:nvSpPr>
         <p:spPr>
           <a:xfrm>
-            <a:off x="540000" y="1440000"/>
-            <a:ext cx="9072000" cy="3797280"/>
+            <a:off x="540000" y="1177920"/>
+            <a:ext cx="9072000" cy="4321800"/>
           </a:xfrm>
           <a:prstGeom prst="rect">
             <a:avLst/>
@@ -5553,7 +5553,127 @@
                 </a:solidFill>
                 <a:latin typeface="Arial"/>
               </a:rPr>
-              <a:t>Habib Yakubu - BD26090891</a:t>
+              <a:t>Habib Yakubu – BD26090891</a:t>
+            </a:r>
+            <a:endParaRPr b="0" lang="en-NG" sz="2800" spc="-1" strike="noStrike">
+              <a:solidFill>
+                <a:srgbClr val="ffffff"/>
+              </a:solidFill>
+              <a:latin typeface="Arial"/>
+            </a:endParaRPr>
+          </a:p>
+          <a:p>
+            <a:pPr>
+              <a:spcBef>
+                <a:spcPts val="283"/>
+              </a:spcBef>
+              <a:spcAft>
+                <a:spcPts val="567"/>
+              </a:spcAft>
+              <a:buClr>
+                <a:srgbClr val="ffffff"/>
+              </a:buClr>
+              <a:buSzPct val="45000"/>
+              <a:buFont typeface="DejaVu Sans"/>
+              <a:buChar char="●"/>
+            </a:pPr>
+            <a:r>
+              <a:rPr b="0" lang="en-NG" sz="2800" spc="-1" strike="noStrike">
+                <a:solidFill>
+                  <a:srgbClr val="ffffff"/>
+                </a:solidFill>
+                <a:latin typeface="Arial"/>
+              </a:rPr>
+              <a:t> </a:t>
+            </a:r>
+            <a:r>
+              <a:rPr b="0" lang="en-NG" sz="2800" spc="-1" strike="noStrike">
+                <a:solidFill>
+                  <a:srgbClr val="ffffff"/>
+                </a:solidFill>
+                <a:latin typeface="Arial"/>
+              </a:rPr>
+              <a:t>Chiemelie Chiadi – BD26090389</a:t>
+            </a:r>
+            <a:endParaRPr b="0" lang="en-NG" sz="2800" spc="-1" strike="noStrike">
+              <a:solidFill>
+                <a:srgbClr val="ffffff"/>
+              </a:solidFill>
+              <a:latin typeface="Arial"/>
+            </a:endParaRPr>
+          </a:p>
+          <a:p>
+            <a:pPr>
+              <a:spcBef>
+                <a:spcPts val="283"/>
+              </a:spcBef>
+              <a:spcAft>
+                <a:spcPts val="567"/>
+              </a:spcAft>
+              <a:buClr>
+                <a:srgbClr val="ffffff"/>
+              </a:buClr>
+              <a:buSzPct val="45000"/>
+              <a:buFont typeface="DejaVu Sans"/>
+              <a:buChar char="●"/>
+            </a:pPr>
+            <a:r>
+              <a:rPr b="0" lang="en-NG" sz="2800" spc="-1" strike="noStrike">
+                <a:solidFill>
+                  <a:srgbClr val="ffffff"/>
+                </a:solidFill>
+                <a:latin typeface="Arial"/>
+              </a:rPr>
+              <a:t> </a:t>
+            </a:r>
+            <a:r>
+              <a:rPr b="0" lang="en-NG" sz="2800" spc="-1" strike="noStrike">
+                <a:solidFill>
+                  <a:srgbClr val="ffffff"/>
+                </a:solidFill>
+                <a:latin typeface="Arial"/>
+              </a:rPr>
+              <a:t>Chizurum – BD26090267</a:t>
+            </a:r>
+            <a:endParaRPr b="0" lang="en-NG" sz="2800" spc="-1" strike="noStrike">
+              <a:solidFill>
+                <a:srgbClr val="ffffff"/>
+              </a:solidFill>
+              <a:latin typeface="Arial"/>
+            </a:endParaRPr>
+          </a:p>
+          <a:p>
+            <a:pPr>
+              <a:spcBef>
+                <a:spcPts val="283"/>
+              </a:spcBef>
+              <a:spcAft>
+                <a:spcPts val="567"/>
+              </a:spcAft>
+              <a:buClr>
+                <a:srgbClr val="ffffff"/>
+              </a:buClr>
+              <a:buSzPct val="45000"/>
+              <a:buFont typeface="DejaVu Sans"/>
+              <a:buChar char="●"/>
+            </a:pPr>
+            <a:r>
+              <a:rPr b="0" lang="en-NG" sz="2800" spc="-1" strike="noStrike">
+                <a:solidFill>
+                  <a:srgbClr val="ffffff"/>
+                </a:solidFill>
+                <a:latin typeface="Arial"/>
+              </a:rPr>
+              <a:t> </a:t>
+            </a:r>
+            <a:r>
+              <a:rPr b="0" lang="en-NG" sz="2800" spc="-1" strike="noStrike">
+                <a:solidFill>
+                  <a:srgbClr val="ffffff"/>
+                </a:solidFill>
+                <a:latin typeface="Arial"/>
+              </a:rPr>
+              <a:t>Laureen - BD26090747</a:t>
             </a:r>
             <a:endParaRPr b="0" lang="en-NG" sz="2800" spc="-1" strike="noStrike">
               <a:solidFill>
@@ -6099,16 +6219,7 @@
                 </a:solidFill>
                 <a:latin typeface="Arial"/>
               </a:rPr>
-              <a:t>To build a working backend </a:t>
-            </a:r>
-            <a:r>
-              <a:rPr b="0" lang="en-NG" sz="2400" spc="-1" strike="noStrike">
-                <a:solidFill>
-                  <a:srgbClr val="ffffff"/>
-                </a:solidFill>
-                <a:latin typeface="Arial"/>
-              </a:rPr>
-              <a:t>API that demonstrates :</a:t>
+              <a:t>To build a working backend API that demonstrates :</a:t>
             </a:r>
             <a:endParaRPr b="0" lang="en-NG" sz="2400" spc="-1" strike="noStrike">
               <a:solidFill>
@@ -6164,16 +6275,7 @@
                 </a:solidFill>
                 <a:latin typeface="Arial"/>
               </a:rPr>
-              <a:t>Structured, maintainable </a:t>
-            </a:r>
-            <a:r>
-              <a:rPr b="0" lang="en-NG" sz="2400" spc="-1" strike="noStrike">
-                <a:solidFill>
-                  <a:srgbClr val="ffffff"/>
-                </a:solidFill>
-                <a:latin typeface="Arial"/>
-              </a:rPr>
-              <a:t>code architecture</a:t>
+              <a:t>Structured, maintainable code architecture</a:t>
             </a:r>
             <a:endParaRPr b="0" lang="en-NG" sz="2400" spc="-1" strike="noStrike">
               <a:solidFill>
@@ -6257,16 +6359,7 @@
                 </a:solidFill>
                 <a:latin typeface="Arial"/>
               </a:rPr>
-              <a:t>Team collaboration using </a:t>
-            </a:r>
-            <a:r>
-              <a:rPr b="0" lang="en-NG" sz="2400" spc="-1" strike="noStrike">
-                <a:solidFill>
-                  <a:srgbClr val="ffffff"/>
-                </a:solidFill>
-                <a:latin typeface="Arial"/>
-              </a:rPr>
-              <a:t>Git/GitHub</a:t>
+              <a:t>Team collaboration using Git/GitHub</a:t>
             </a:r>
             <a:endParaRPr b="0" lang="en-NG" sz="2400" spc="-1" strike="noStrike">
               <a:solidFill>
@@ -7718,52 +7811,7 @@
                 </a:solidFill>
                 <a:latin typeface="Arial"/>
               </a:rPr>
-              <a:t>The project follows the MVC </a:t>
-            </a:r>
-            <a:r>
-              <a:rPr b="0" lang="en-NG" sz="2400" spc="-1" strike="noStrike">
-                <a:solidFill>
-                  <a:srgbClr val="ffffff"/>
-                </a:solidFill>
-                <a:latin typeface="Arial"/>
-              </a:rPr>
-              <a:t>(Model-View-Controller) </a:t>
-            </a:r>
-            <a:r>
-              <a:rPr b="0" lang="en-NG" sz="2400" spc="-1" strike="noStrike">
-                <a:solidFill>
-                  <a:srgbClr val="ffffff"/>
-                </a:solidFill>
-                <a:latin typeface="Arial"/>
-              </a:rPr>
-              <a:t>architectural pattern, adapted </a:t>
-            </a:r>
-            <a:r>
-              <a:rPr b="0" lang="en-NG" sz="2400" spc="-1" strike="noStrike">
-                <a:solidFill>
-                  <a:srgbClr val="ffffff"/>
-                </a:solidFill>
-                <a:latin typeface="Arial"/>
-              </a:rPr>
-              <a:t>for an API (no “view” layer </a:t>
-            </a:r>
-            <a:r>
-              <a:rPr b="0" lang="en-NG" sz="2400" spc="-1" strike="noStrike">
-                <a:solidFill>
-                  <a:srgbClr val="ffffff"/>
-                </a:solidFill>
-                <a:latin typeface="Arial"/>
-              </a:rPr>
-              <a:t>since this is a backend-only </a:t>
-            </a:r>
-            <a:r>
-              <a:rPr b="0" lang="en-NG" sz="2400" spc="-1" strike="noStrike">
-                <a:solidFill>
-                  <a:srgbClr val="ffffff"/>
-                </a:solidFill>
-                <a:latin typeface="Arial"/>
-              </a:rPr>
-              <a:t>service returning JSON):</a:t>
+              <a:t>The project follows the MVC (Model-View-Controller) architectural pattern, adapted for an API (no “view” layer since this is a backend-only service returning JSON):</a:t>
             </a:r>
             <a:endParaRPr b="0" lang="en-NG" sz="2400" spc="-1" strike="noStrike">
               <a:solidFill>
@@ -7791,34 +7839,7 @@
                 </a:solidFill>
                 <a:latin typeface="Arial"/>
               </a:rPr>
-              <a:t>Model / Data layer – handles </a:t>
-            </a:r>
-            <a:r>
-              <a:rPr b="0" lang="en-NG" sz="2400" spc="-1" strike="noStrike">
-                <a:solidFill>
-                  <a:srgbClr val="ffffff"/>
-                </a:solidFill>
-                <a:latin typeface="Arial"/>
-              </a:rPr>
-              <a:t>how the data is stored and </a:t>
-            </a:r>
-            <a:r>
-              <a:rPr b="0" lang="en-NG" sz="2400" spc="-1" strike="noStrike">
-                <a:solidFill>
-                  <a:srgbClr val="ffffff"/>
-                </a:solidFill>
-                <a:latin typeface="Arial"/>
-              </a:rPr>
-              <a:t>retrieved (database + </a:t>
-            </a:r>
-            <a:r>
-              <a:rPr b="0" lang="en-NG" sz="2400" spc="-1" strike="noStrike">
-                <a:solidFill>
-                  <a:srgbClr val="ffffff"/>
-                </a:solidFill>
-                <a:latin typeface="Arial"/>
-              </a:rPr>
-              <a:t>repository)</a:t>
+              <a:t>Model / Data layer – handles how the data is stored and retrieved (database + repository)</a:t>
             </a:r>
             <a:endParaRPr b="0" lang="en-NG" sz="2400" spc="-1" strike="noStrike">
               <a:solidFill>
@@ -7846,25 +7867,7 @@
                 </a:solidFill>
                 <a:latin typeface="Arial"/>
               </a:rPr>
-              <a:t>Controller – contains the </a:t>
-            </a:r>
-            <a:r>
-              <a:rPr b="0" lang="en-NG" sz="2400" spc="-1" strike="noStrike">
-                <a:solidFill>
-                  <a:srgbClr val="ffffff"/>
-                </a:solidFill>
-                <a:latin typeface="Arial"/>
-              </a:rPr>
-              <a:t>logic for handling each </a:t>
-            </a:r>
-            <a:r>
-              <a:rPr b="0" lang="en-NG" sz="2400" spc="-1" strike="noStrike">
-                <a:solidFill>
-                  <a:srgbClr val="ffffff"/>
-                </a:solidFill>
-                <a:latin typeface="Arial"/>
-              </a:rPr>
-              <a:t>request</a:t>
+              <a:t>Controller – contains the logic for handling each request</a:t>
             </a:r>
             <a:endParaRPr b="0" lang="en-NG" sz="2400" spc="-1" strike="noStrike">
               <a:solidFill>
@@ -7892,25 +7895,7 @@
                 </a:solidFill>
                 <a:latin typeface="Arial"/>
               </a:rPr>
-              <a:t>Routes – map incoming </a:t>
-            </a:r>
-            <a:r>
-              <a:rPr b="0" lang="en-NG" sz="2400" spc="-1" strike="noStrike">
-                <a:solidFill>
-                  <a:srgbClr val="ffffff"/>
-                </a:solidFill>
-                <a:latin typeface="Arial"/>
-              </a:rPr>
-              <a:t>HTTP requests to the correct </a:t>
-            </a:r>
-            <a:r>
-              <a:rPr b="0" lang="en-NG" sz="2400" spc="-1" strike="noStrike">
-                <a:solidFill>
-                  <a:srgbClr val="ffffff"/>
-                </a:solidFill>
-                <a:latin typeface="Arial"/>
-              </a:rPr>
-              <a:t>controller function.</a:t>
+              <a:t>Routes – map incoming HTTP requests to the correct controller function.</a:t>
             </a:r>
             <a:endParaRPr b="0" lang="en-NG" sz="2400" spc="-1" strike="noStrike">
               <a:solidFill>
@@ -7933,61 +7918,7 @@
                 </a:solidFill>
                 <a:latin typeface="Arial"/>
               </a:rPr>
-              <a:t>This separation keeps each </a:t>
-            </a:r>
-            <a:r>
-              <a:rPr b="0" lang="en-NG" sz="2400" spc="-1" strike="noStrike">
-                <a:solidFill>
-                  <a:srgbClr val="ffffff"/>
-                </a:solidFill>
-                <a:latin typeface="Arial"/>
-              </a:rPr>
-              <a:t>part of the codebase focused </a:t>
-            </a:r>
-            <a:r>
-              <a:rPr b="0" lang="en-NG" sz="2400" spc="-1" strike="noStrike">
-                <a:solidFill>
-                  <a:srgbClr val="ffffff"/>
-                </a:solidFill>
-                <a:latin typeface="Arial"/>
-              </a:rPr>
-              <a:t>on a songle responsibility, </a:t>
-            </a:r>
-            <a:r>
-              <a:rPr b="0" lang="en-NG" sz="2400" spc="-1" strike="noStrike">
-                <a:solidFill>
-                  <a:srgbClr val="ffffff"/>
-                </a:solidFill>
-                <a:latin typeface="Arial"/>
-              </a:rPr>
-              <a:t>making the project easier for </a:t>
-            </a:r>
-            <a:r>
-              <a:rPr b="0" lang="en-NG" sz="2400" spc="-1" strike="noStrike">
-                <a:solidFill>
-                  <a:srgbClr val="ffffff"/>
-                </a:solidFill>
-                <a:latin typeface="Arial"/>
-              </a:rPr>
-              <a:t>multiple people to work on </a:t>
-            </a:r>
-            <a:r>
-              <a:rPr b="0" lang="en-NG" sz="2400" spc="-1" strike="noStrike">
-                <a:solidFill>
-                  <a:srgbClr val="ffffff"/>
-                </a:solidFill>
-                <a:latin typeface="Arial"/>
-              </a:rPr>
-              <a:t>sumultaneously without </a:t>
-            </a:r>
-            <a:r>
-              <a:rPr b="0" lang="en-NG" sz="2400" spc="-1" strike="noStrike">
-                <a:solidFill>
-                  <a:srgbClr val="ffffff"/>
-                </a:solidFill>
-                <a:latin typeface="Arial"/>
-              </a:rPr>
-              <a:t>conflicts.</a:t>
+              <a:t>This separation keeps each part of the codebase focused on a songle responsibility, making the project easier for multiple people to work on sumultaneously without conflicts.</a:t>
             </a:r>
             <a:endParaRPr b="0" lang="en-NG" sz="2400" spc="-1" strike="noStrike">
               <a:solidFill>
@@ -8791,34 +8722,16 @@
                 </a:solidFill>
                 <a:latin typeface="Arial"/>
               </a:rPr>
-              <a:t> – Wrote </a:t>
-            </a:r>
-            <a:r>
-              <a:rPr b="0" lang="en-NG" sz="2400" spc="-1" strike="noStrike">
-                <a:solidFill>
-                  <a:srgbClr val="ffffff"/>
-                </a:solidFill>
-                <a:latin typeface="Arial"/>
-              </a:rPr>
-              <a:t>automated tests to verify the </a:t>
-            </a:r>
-            <a:r>
-              <a:rPr b="0" lang="en-NG" sz="2400" spc="-1" strike="noStrike">
-                <a:solidFill>
-                  <a:srgbClr val="ffffff"/>
-                </a:solidFill>
-                <a:latin typeface="Arial"/>
-              </a:rPr>
-              <a:t>repository functions worked </a:t>
-            </a:r>
-            <a:r>
-              <a:rPr b="0" lang="en-NG" sz="2400" spc="-1" strike="noStrike">
-                <a:solidFill>
-                  <a:srgbClr val="ffffff"/>
-                </a:solidFill>
-                <a:latin typeface="Arial"/>
-              </a:rPr>
-              <a:t>correctly.</a:t>
+              <a:t> – Wrote automated tests to verify the </a:t>
+            </a:r>
+            <a:r>
+              <a:rPr b="0" lang="en-NG" sz="2400" spc="-1" strike="noStrike">
+                <a:solidFill>
+                  <a:srgbClr val="ffffff"/>
+                </a:solidFill>
+                <a:latin typeface="Arial"/>
+              </a:rPr>
+              <a:t>repository functions worked correctly.</a:t>
             </a:r>
             <a:endParaRPr b="0" lang="en-NG" sz="2400" spc="-1" strike="noStrike">
               <a:solidFill>
@@ -8860,52 +8773,25 @@
                 </a:solidFill>
                 <a:latin typeface="Arial"/>
               </a:rPr>
-              <a:t> – </a:t>
-            </a:r>
-            <a:r>
-              <a:rPr b="0" lang="en-NG" sz="2400" spc="-1" strike="noStrike">
-                <a:solidFill>
-                  <a:srgbClr val="ffffff"/>
-                </a:solidFill>
-                <a:latin typeface="Arial"/>
-              </a:rPr>
-              <a:t>Built middleware to check </a:t>
-            </a:r>
-            <a:r>
-              <a:rPr b="0" lang="en-NG" sz="2400" spc="-1" strike="noStrike">
-                <a:solidFill>
-                  <a:srgbClr val="ffffff"/>
-                </a:solidFill>
-                <a:latin typeface="Arial"/>
-              </a:rPr>
-              <a:t>incoming request, ensuring </a:t>
-            </a:r>
-            <a:r>
-              <a:rPr b="0" lang="en-NG" sz="2400" spc="-1" strike="noStrike">
-                <a:solidFill>
-                  <a:srgbClr val="ffffff"/>
-                </a:solidFill>
-                <a:latin typeface="Arial"/>
-              </a:rPr>
-              <a:t>they included the correct </a:t>
-            </a:r>
-            <a:r>
-              <a:rPr b="0" lang="en-NG" sz="2400" spc="-1" strike="noStrike">
-                <a:solidFill>
-                  <a:srgbClr val="ffffff"/>
-                </a:solidFill>
-                <a:latin typeface="Arial"/>
-              </a:rPr>
-              <a:t>headers, body and required </a:t>
-            </a:r>
-            <a:r>
-              <a:rPr b="0" lang="en-NG" sz="2400" spc="-1" strike="noStrike">
-                <a:solidFill>
-                  <a:srgbClr val="ffffff"/>
-                </a:solidFill>
-                <a:latin typeface="Arial"/>
-              </a:rPr>
-              <a:t>data before being processed.</a:t>
+              <a:t> – Built middleware to check incoming </a:t>
+            </a:r>
+            <a:r>
+              <a:rPr b="0" lang="en-NG" sz="2400" spc="-1" strike="noStrike">
+                <a:solidFill>
+                  <a:srgbClr val="ffffff"/>
+                </a:solidFill>
+                <a:latin typeface="Arial"/>
+              </a:rPr>
+              <a:t>request, ensuring they included the correct headers, body and </a:t>
+            </a:r>
+            <a:r>
+              <a:rPr b="0" lang="en-NG" sz="2400" spc="-1" strike="noStrike">
+                <a:solidFill>
+                  <a:srgbClr val="ffffff"/>
+                </a:solidFill>
+                <a:latin typeface="Arial"/>
+              </a:rPr>
+              <a:t>required data before being processed.</a:t>
             </a:r>
             <a:endParaRPr b="0" lang="en-NG" sz="2400" spc="-1" strike="noStrike">
               <a:solidFill>
@@ -8947,16 +8833,7 @@
                 </a:solidFill>
                 <a:latin typeface="Arial"/>
               </a:rPr>
-              <a:t> – Implemented </a:t>
-            </a:r>
-            <a:r>
-              <a:rPr b="0" lang="en-NG" sz="2400" spc="-1" strike="noStrike">
-                <a:solidFill>
-                  <a:srgbClr val="ffffff"/>
-                </a:solidFill>
-                <a:latin typeface="Arial"/>
-              </a:rPr>
-              <a:t>the route to fetch notes.</a:t>
+              <a:t> – Implemented the route to fetch notes.</a:t>
             </a:r>
             <a:endParaRPr b="0" lang="en-NG" sz="2400" spc="-1" strike="noStrike">
               <a:solidFill>
@@ -8998,25 +8875,7 @@
                 </a:solidFill>
                 <a:latin typeface="Arial"/>
               </a:rPr>
-              <a:t> – </a:t>
-            </a:r>
-            <a:r>
-              <a:rPr b="0" lang="en-NG" sz="2400" spc="-1" strike="noStrike">
-                <a:solidFill>
-                  <a:srgbClr val="ffffff"/>
-                </a:solidFill>
-                <a:latin typeface="Arial"/>
-              </a:rPr>
-              <a:t>Implemented  the route to </a:t>
-            </a:r>
-            <a:r>
-              <a:rPr b="0" lang="en-NG" sz="2400" spc="-1" strike="noStrike">
-                <a:solidFill>
-                  <a:srgbClr val="ffffff"/>
-                </a:solidFill>
-                <a:latin typeface="Arial"/>
-              </a:rPr>
-              <a:t>remove notes.</a:t>
+              <a:t> – Implemented  the route to remove notes.</a:t>
             </a:r>
             <a:endParaRPr b="0" lang="en-NG" sz="2400" spc="-1" strike="noStrike">
               <a:solidFill>

</xml_diff>